<commit_message>
Verify Nightshift cloud inference and finalize disclosed submission assets
</commit_message>
<xml_diff>
--- a/submission/claimtrace-slides.pptx
+++ b/submission/claimtrace-slides.pptx
@@ -2,18 +2,18 @@
 <file path=ppt/presentation.xml><?xml version="1.0" encoding="utf-8"?>
 <p:presentation xmlns:p="http://schemas.openxmlformats.org/presentationml/2006/main">
   <p:sldMasterIdLst>
-    <p:sldMasterId xmlns:r="http://schemas.openxmlformats.org/officeDocument/2006/relationships" id="2147483648" r:id="R7d84ba658a6146a6"/>
+    <p:sldMasterId xmlns:r="http://schemas.openxmlformats.org/officeDocument/2006/relationships" id="2147483648" r:id="R37a70294b26b4f6b"/>
   </p:sldMasterIdLst>
   <p:notesMasterIdLst>
-    <p:notesMasterId xmlns:r="http://schemas.openxmlformats.org/officeDocument/2006/relationships" r:id="Ra34169c4f7cc42ab"/>
+    <p:notesMasterId xmlns:r="http://schemas.openxmlformats.org/officeDocument/2006/relationships" r:id="R4ed4990814b54f93"/>
   </p:notesMasterIdLst>
   <p:sldIdLst>
-    <p:sldId xmlns:r="http://schemas.openxmlformats.org/officeDocument/2006/relationships" id="256" r:id="Rb7f4774b5aa748eb"/>
-    <p:sldId xmlns:r="http://schemas.openxmlformats.org/officeDocument/2006/relationships" id="257" r:id="R4300bba969e5495c"/>
-    <p:sldId xmlns:r="http://schemas.openxmlformats.org/officeDocument/2006/relationships" id="258" r:id="Rbb5a3b3765ed41aa"/>
-    <p:sldId xmlns:r="http://schemas.openxmlformats.org/officeDocument/2006/relationships" id="259" r:id="Rcfd68f046f074a4b"/>
-    <p:sldId xmlns:r="http://schemas.openxmlformats.org/officeDocument/2006/relationships" id="260" r:id="R604b549aadb54f4a"/>
-    <p:sldId xmlns:r="http://schemas.openxmlformats.org/officeDocument/2006/relationships" id="261" r:id="Rb7e8490b1b844319"/>
+    <p:sldId xmlns:r="http://schemas.openxmlformats.org/officeDocument/2006/relationships" id="256" r:id="R79908aaf58a2411a"/>
+    <p:sldId xmlns:r="http://schemas.openxmlformats.org/officeDocument/2006/relationships" id="257" r:id="R91c9c8ed18904927"/>
+    <p:sldId xmlns:r="http://schemas.openxmlformats.org/officeDocument/2006/relationships" id="258" r:id="R4cc0fdef8f7d4caa"/>
+    <p:sldId xmlns:r="http://schemas.openxmlformats.org/officeDocument/2006/relationships" id="259" r:id="R4d6045ac1cbc4434"/>
+    <p:sldId xmlns:r="http://schemas.openxmlformats.org/officeDocument/2006/relationships" id="260" r:id="Re627589c2ee34ec1"/>
+    <p:sldId xmlns:r="http://schemas.openxmlformats.org/officeDocument/2006/relationships" id="261" r:id="R249d01028b884cc7"/>
   </p:sldIdLst>
   <p:sldSz cx="12192000" cy="6858000"/>
   <p:notesSz cx="6858000" cy="9144000"/>
@@ -727,7 +727,7 @@
           <a:lstStyle xmlns:a="http://schemas.openxmlformats.org/drawingml/2006/main"/>
           <a:p xmlns:a="http://schemas.openxmlformats.org/drawingml/2006/main">
             <a:r>
-              <a:t>Sponsor evidence: README.md integration matrix; docs/nightshift-windows-activation.md; docs/nvidia-activation.md; work/live-sponsor-qa.md. Nightshift 1.2.7 status/discover both E_UNREACHABLE, exit12. Laptop integrated Intel Iris Xe/8GB does not meet published dedicated GPU requirements; supported cloud-only startup unverified. No local model was loaded. Direct NVIDIA does not satisfy the mandatory Nightshift-provider requirement. H-MEM actual engine execution is separate from Nightshift inference. No qualifying Cursor contribution follows from installation.</a:t>
+              <a:t>Sponsor evidence: README.md integration matrix; docs/nightshift-windows-activation.md; docs/nvidia-activation.md; work/live-sponsor-qa.md. The owner manually started Nightshift 1.2.7. Actual CLI status/discover now succeed and the cloud preview runtime is reachable. Authenticated model discovery succeeded. A real uncached cloud NVIDIA Lightning smoke completion matched the requested model and provider. One bounded financial dispatcher run returned a real uncached native proposal, receipt rcpt_req_6ma1r4ho. The host rejected the proposal before claim registration or evidence retrieval. The run collected zero evidence and accepted no conclusion. Human review remains required. No completed model financial investigation is claimed. No local model was loaded. Direct NVIDIA does not satisfy the mandatory Nightshift-provider requirement. H-MEM actual engine execution is separate from Nightshift inference. No qualifying Cursor contribution follows from installation.</a:t>
             </a:r>
           </a:p>
         </p:txBody>
@@ -797,7 +797,7 @@
           <a:lstStyle xmlns:a="http://schemas.openxmlformats.org/drawingml/2006/main"/>
           <a:p xmlns:a="http://schemas.openxmlformats.org/drawingml/2006/main">
             <a:r>
-              <a:t>Final organizer checklist supplied by the project lead October26: working end-to-end application, tested Zetaris, functioning Meterless Engine feature, Nightshift as AI provider, genuine traces, three README samples, 1–4-minute video, deck, accessible GitHub repository and accurate disclosures. This deck does not authorize merge, deploy, publishing, judge invitations or submission. Video existence/duration must be checked by the lead separately; no recorded video is claimed here.</a:t>
+              <a:t>Final organizer checklist supplied by the project lead: working end-to-end application, tested Zetaris, functioning Meterless Engine feature, Nightshift as AI provider, genuine traces, three README samples, 1–4-minute video, deck, accessible GitHub repository and accurate disclosures. Current saved main is 0a6f6fb, with PRs7–13 merged. This deck does not authorize deploy, publishing, judge invitations or submission. Authenticated Nightshift smoke inference is now verified, separately from the rejected native financial proposal. Evidence receipts: work/nightshift-investigation.json and .local/nightshift-smoke.json. The financial run collected zero evidence, produced no accepted conclusion, and requires human review. HackOS solo-Amari draft and media uploads are prepared but not submitted. Cursor remains optional under the current official rules, and no qualifying contribution is claimed. Video existence/duration must be checked by the lead separately; no recorded video is claimed here.</a:t>
             </a:r>
           </a:p>
         </p:txBody>
@@ -844,7 +844,7 @@
           <p:cNvPr id="3" name="Title">
             <a:extLst xmlns:a="http://schemas.openxmlformats.org/drawingml/2006/main">
               <a:ext uri="{FF2B5EF4-FFF2-40B4-BE49-F238E27FC236}">
-                <a16:creationId xmlns:a16="http://schemas.microsoft.com/office/drawing/2014/main" id="{AFB775D4-BA02-4D3C-BA66-5CBF38B68ECF}"/>
+                <a16:creationId xmlns:a16="http://schemas.microsoft.com/office/drawing/2014/main" id="{275B6409-28E5-45AB-9ACE-4E30D8B7E41C}"/>
               </a:ext>
             </a:extLst>
           </p:cNvPr>
@@ -1073,7 +1073,7 @@
           <p:cNvPr id="2" name="Subtitle">
             <a:extLst xmlns:a="http://schemas.openxmlformats.org/drawingml/2006/main">
               <a:ext uri="{FF2B5EF4-FFF2-40B4-BE49-F238E27FC236}">
-                <a16:creationId xmlns:a16="http://schemas.microsoft.com/office/drawing/2014/main" id="{90D10ACC-4FFC-494B-B4DF-E976A62D1A07}"/>
+                <a16:creationId xmlns:a16="http://schemas.microsoft.com/office/drawing/2014/main" id="{66538F29-4C05-4D7B-B4A7-DC4339F3F96F}"/>
               </a:ext>
             </a:extLst>
           </p:cNvPr>
@@ -1319,7 +1319,7 @@
           <p:cNvPr id="2" name="Section title">
             <a:extLst xmlns:a="http://schemas.openxmlformats.org/drawingml/2006/main">
               <a:ext uri="{FF2B5EF4-FFF2-40B4-BE49-F238E27FC236}">
-                <a16:creationId xmlns:a16="http://schemas.microsoft.com/office/drawing/2014/main" id="{5865CAFA-AB15-4C71-A40D-F3F1E98C7AE7}"/>
+                <a16:creationId xmlns:a16="http://schemas.microsoft.com/office/drawing/2014/main" id="{365BD3E0-AF13-4309-98BC-AF4DA2B6D033}"/>
               </a:ext>
             </a:extLst>
           </p:cNvPr>
@@ -1565,7 +1565,7 @@
           <p:cNvPr id="3" name="Title">
             <a:extLst xmlns:a="http://schemas.openxmlformats.org/drawingml/2006/main">
               <a:ext uri="{FF2B5EF4-FFF2-40B4-BE49-F238E27FC236}">
-                <a16:creationId xmlns:a16="http://schemas.microsoft.com/office/drawing/2014/main" id="{BF6033D1-8B3E-434E-BE4B-7ECABA9E8838}"/>
+                <a16:creationId xmlns:a16="http://schemas.microsoft.com/office/drawing/2014/main" id="{F29941EB-67F0-4567-9DFA-17DF01731FC1}"/>
               </a:ext>
             </a:extLst>
           </p:cNvPr>
@@ -1794,7 +1794,7 @@
           <p:cNvPr id="2" name="Body">
             <a:extLst xmlns:a="http://schemas.openxmlformats.org/drawingml/2006/main">
               <a:ext uri="{FF2B5EF4-FFF2-40B4-BE49-F238E27FC236}">
-                <a16:creationId xmlns:a16="http://schemas.microsoft.com/office/drawing/2014/main" id="{D3F0CE50-F880-4B23-8885-03BE2F229674}"/>
+                <a16:creationId xmlns:a16="http://schemas.microsoft.com/office/drawing/2014/main" id="{B41BFA12-0FF2-430B-817C-9FE887C45719}"/>
               </a:ext>
             </a:extLst>
           </p:cNvPr>
@@ -2040,7 +2040,7 @@
           <p:cNvPr id="4" name="Title">
             <a:extLst xmlns:a="http://schemas.openxmlformats.org/drawingml/2006/main">
               <a:ext uri="{FF2B5EF4-FFF2-40B4-BE49-F238E27FC236}">
-                <a16:creationId xmlns:a16="http://schemas.microsoft.com/office/drawing/2014/main" id="{9C6889DF-3BF2-41AB-9F6F-F27643729196}"/>
+                <a16:creationId xmlns:a16="http://schemas.microsoft.com/office/drawing/2014/main" id="{D04E1D18-5238-40F7-A04F-A050750CDB3B}"/>
               </a:ext>
             </a:extLst>
           </p:cNvPr>
@@ -2269,7 +2269,7 @@
           <p:cNvPr id="2" name="Left column">
             <a:extLst xmlns:a="http://schemas.openxmlformats.org/drawingml/2006/main">
               <a:ext uri="{FF2B5EF4-FFF2-40B4-BE49-F238E27FC236}">
-                <a16:creationId xmlns:a16="http://schemas.microsoft.com/office/drawing/2014/main" id="{91292271-DA49-4DC0-9F0F-6EDBB6C9ECB9}"/>
+                <a16:creationId xmlns:a16="http://schemas.microsoft.com/office/drawing/2014/main" id="{02213A38-209B-4E8C-B1B5-936A143F175D}"/>
               </a:ext>
             </a:extLst>
           </p:cNvPr>
@@ -2498,7 +2498,7 @@
           <p:cNvPr id="3" name="Right column">
             <a:extLst xmlns:a="http://schemas.openxmlformats.org/drawingml/2006/main">
               <a:ext uri="{FF2B5EF4-FFF2-40B4-BE49-F238E27FC236}">
-                <a16:creationId xmlns:a16="http://schemas.microsoft.com/office/drawing/2014/main" id="{13438047-9B1D-4944-975C-BBE15F024A0E}"/>
+                <a16:creationId xmlns:a16="http://schemas.microsoft.com/office/drawing/2014/main" id="{5DC2CDC4-6223-4E24-B5CF-A3237E218E20}"/>
               </a:ext>
             </a:extLst>
           </p:cNvPr>
@@ -2744,7 +2744,7 @@
           <p:cNvPr id="3" name="Title">
             <a:extLst xmlns:a="http://schemas.openxmlformats.org/drawingml/2006/main">
               <a:ext uri="{FF2B5EF4-FFF2-40B4-BE49-F238E27FC236}">
-                <a16:creationId xmlns:a16="http://schemas.microsoft.com/office/drawing/2014/main" id="{7E0753BA-E987-47D7-B3D0-7CFD839E2D9E}"/>
+                <a16:creationId xmlns:a16="http://schemas.microsoft.com/office/drawing/2014/main" id="{E184662B-64C3-488A-8221-F746D6F1EDFE}"/>
               </a:ext>
             </a:extLst>
           </p:cNvPr>
@@ -2973,7 +2973,7 @@
           <p:cNvPr id="2" name="Left column">
             <a:extLst xmlns:a="http://schemas.openxmlformats.org/drawingml/2006/main">
               <a:ext uri="{FF2B5EF4-FFF2-40B4-BE49-F238E27FC236}">
-                <a16:creationId xmlns:a16="http://schemas.microsoft.com/office/drawing/2014/main" id="{1B6F06D1-5242-43A1-9509-0D425356D478}"/>
+                <a16:creationId xmlns:a16="http://schemas.microsoft.com/office/drawing/2014/main" id="{AF4A7399-59DC-4069-9126-C49FB2D3E441}"/>
               </a:ext>
             </a:extLst>
           </p:cNvPr>
@@ -3240,12 +3240,12 @@
   </p:cSld>
   <p:clrMap bg1="lt1" tx1="dk1" bg2="lt2" tx2="dk2" accent1="accent1" accent2="accent2" accent3="accent3" accent4="accent4" accent5="accent5" accent6="accent6" hlink="hlink" folHlink="folHlink"/>
   <p:sldLayoutIdLst>
-    <p:sldLayoutId xmlns:r="http://schemas.openxmlformats.org/officeDocument/2006/relationships" id="2147483649" r:id="R113c686137a443d5"/>
-    <p:sldLayoutId xmlns:r="http://schemas.openxmlformats.org/officeDocument/2006/relationships" id="2147483650" r:id="R0faa7410f42e48bc"/>
-    <p:sldLayoutId xmlns:r="http://schemas.openxmlformats.org/officeDocument/2006/relationships" id="2147483651" r:id="R57a42461ce7046a3"/>
-    <p:sldLayoutId xmlns:r="http://schemas.openxmlformats.org/officeDocument/2006/relationships" id="2147483652" r:id="R45cb9b36d81c4ec6"/>
-    <p:sldLayoutId xmlns:r="http://schemas.openxmlformats.org/officeDocument/2006/relationships" id="2147483653" r:id="R600f341481b04e47"/>
-    <p:sldLayoutId xmlns:r="http://schemas.openxmlformats.org/officeDocument/2006/relationships" id="2147483654" r:id="R6a6fd93054414d72"/>
+    <p:sldLayoutId xmlns:r="http://schemas.openxmlformats.org/officeDocument/2006/relationships" id="2147483649" r:id="Rfc349f453dfb4587"/>
+    <p:sldLayoutId xmlns:r="http://schemas.openxmlformats.org/officeDocument/2006/relationships" id="2147483650" r:id="R9e2275d1ab56420a"/>
+    <p:sldLayoutId xmlns:r="http://schemas.openxmlformats.org/officeDocument/2006/relationships" id="2147483651" r:id="Rc7b7d0f095e84658"/>
+    <p:sldLayoutId xmlns:r="http://schemas.openxmlformats.org/officeDocument/2006/relationships" id="2147483652" r:id="R2114f04f9f44401d"/>
+    <p:sldLayoutId xmlns:r="http://schemas.openxmlformats.org/officeDocument/2006/relationships" id="2147483653" r:id="R06af528be9ee4fbd"/>
+    <p:sldLayoutId xmlns:r="http://schemas.openxmlformats.org/officeDocument/2006/relationships" id="2147483654" r:id="R386993156ad84d4c"/>
   </p:sldLayoutIdLst>
   <p:txStyles>
     <p:titleStyle>
@@ -3796,7 +3796,7 @@
           <p:cNvPr id="5" name="">
             <a:extLst xmlns:a="http://schemas.openxmlformats.org/drawingml/2006/main">
               <a:ext uri="{FF2B5EF4-FFF2-40B4-BE49-F238E27FC236}">
-                <a16:creationId xmlns:a16="http://schemas.microsoft.com/office/drawing/2014/main" id="{A8AD2792-7A5D-4EB6-B635-B1FC72E21EF7}"/>
+                <a16:creationId xmlns:a16="http://schemas.microsoft.com/office/drawing/2014/main" id="{BF6824A5-E924-455A-A129-2BB12290FA51}"/>
               </a:ext>
             </a:extLst>
           </p:cNvPr>
@@ -3952,7 +3952,7 @@
           <p:cNvPr id="2" name="">
             <a:extLst xmlns:a="http://schemas.openxmlformats.org/drawingml/2006/main">
               <a:ext uri="{FF2B5EF4-FFF2-40B4-BE49-F238E27FC236}">
-                <a16:creationId xmlns:a16="http://schemas.microsoft.com/office/drawing/2014/main" id="{CA90849A-3D16-4B70-B92A-3135B494A7EC}"/>
+                <a16:creationId xmlns:a16="http://schemas.microsoft.com/office/drawing/2014/main" id="{E86E202C-7811-424C-9255-6F0A4598C78A}"/>
               </a:ext>
             </a:extLst>
           </p:cNvPr>
@@ -4108,7 +4108,7 @@
           <p:cNvPr id="3" name="">
             <a:extLst xmlns:a="http://schemas.openxmlformats.org/drawingml/2006/main">
               <a:ext uri="{FF2B5EF4-FFF2-40B4-BE49-F238E27FC236}">
-                <a16:creationId xmlns:a16="http://schemas.microsoft.com/office/drawing/2014/main" id="{84E336F3-8D6A-44FB-AE3D-621007E64022}"/>
+                <a16:creationId xmlns:a16="http://schemas.microsoft.com/office/drawing/2014/main" id="{39E1DADC-175E-47BF-83A9-E539A7690B74}"/>
               </a:ext>
             </a:extLst>
           </p:cNvPr>
@@ -4264,7 +4264,7 @@
           <p:cNvPr id="4" name="">
             <a:extLst xmlns:a="http://schemas.openxmlformats.org/drawingml/2006/main">
               <a:ext uri="{FF2B5EF4-FFF2-40B4-BE49-F238E27FC236}">
-                <a16:creationId xmlns:a16="http://schemas.microsoft.com/office/drawing/2014/main" id="{DA7B9A3D-76EB-42B6-90A2-B7ABBDB29128}"/>
+                <a16:creationId xmlns:a16="http://schemas.microsoft.com/office/drawing/2014/main" id="{EF537A40-2678-44DA-B374-24CE0A696FE9}"/>
               </a:ext>
             </a:extLst>
           </p:cNvPr>
@@ -4410,7 +4410,7 @@
                 <a:ea typeface="Arial"/>
                 <a:cs typeface="Arial"/>
               </a:rPr>
-              <a:t>Internal review • October 26, 2026</a:t>
+              <a:t>Internal review • October 27, 2026</a:t>
             </a:r>
           </a:p>
           <a:p xmlns:a="http://schemas.openxmlformats.org/drawingml/2006/main">
@@ -4433,7 +4433,7 @@
                 <a:ea typeface="Arial"/>
                 <a:cs typeface="Arial"/>
               </a:rPr>
-              <a:t>Mandatory Nightshift provider integration remains unmet</a:t>
+              <a:t>Nightshift inference verified; complete AI investigation remains unmet</a:t>
             </a:r>
           </a:p>
         </p:txBody>
@@ -4441,7 +4441,7 @@
     </p:spTree>
     <p:extLst>
       <p:ext uri="{BB962C8B-B14F-4D97-AF65-F5344CB8AC3E}">
-        <p14:creationId xmlns:p14="http://schemas.microsoft.com/office/powerpoint/2010/main" val="1163706776"/>
+        <p14:creationId xmlns:p14="http://schemas.microsoft.com/office/powerpoint/2010/main" val="1243759380"/>
       </p:ext>
     </p:extLst>
   </p:cSld>
@@ -4472,7 +4472,7 @@
           <p:cNvPr id="5" name="">
             <a:extLst xmlns:a="http://schemas.openxmlformats.org/drawingml/2006/main">
               <a:ext uri="{FF2B5EF4-FFF2-40B4-BE49-F238E27FC236}">
-                <a16:creationId xmlns:a16="http://schemas.microsoft.com/office/drawing/2014/main" id="{02C381D8-7D76-4839-A045-3EE228DEA9CE}"/>
+                <a16:creationId xmlns:a16="http://schemas.microsoft.com/office/drawing/2014/main" id="{BBEF35C9-4CE4-47B4-AC02-11F8130E82AC}"/>
               </a:ext>
             </a:extLst>
           </p:cNvPr>
@@ -4628,7 +4628,7 @@
           <p:cNvPr id="2" name="">
             <a:extLst xmlns:a="http://schemas.openxmlformats.org/drawingml/2006/main">
               <a:ext uri="{FF2B5EF4-FFF2-40B4-BE49-F238E27FC236}">
-                <a16:creationId xmlns:a16="http://schemas.microsoft.com/office/drawing/2014/main" id="{7D5F1750-3FEC-40D3-9478-604A0EC0A9A1}"/>
+                <a16:creationId xmlns:a16="http://schemas.microsoft.com/office/drawing/2014/main" id="{BD4EC3F2-9577-4206-AABF-2384DDA1A9DE}"/>
               </a:ext>
             </a:extLst>
           </p:cNvPr>
@@ -4774,7 +4774,7 @@
                 <a:ea typeface="Arial"/>
                 <a:cs typeface="Arial"/>
               </a:rPr>
-              <a:t>INTERNAL REVIEW  •  Nightshift provider requirement unmet  •  2/6</a:t>
+              <a:t>INTERNAL REVIEW  •  Complete AI investigation remains unmet  •  2/6</a:t>
             </a:r>
           </a:p>
         </p:txBody>
@@ -4784,7 +4784,7 @@
           <p:cNvPr id="3" name="">
             <a:extLst xmlns:a="http://schemas.openxmlformats.org/drawingml/2006/main">
               <a:ext uri="{FF2B5EF4-FFF2-40B4-BE49-F238E27FC236}">
-                <a16:creationId xmlns:a16="http://schemas.microsoft.com/office/drawing/2014/main" id="{B4D21D9C-D646-41F2-9F57-B125B56D1B79}"/>
+                <a16:creationId xmlns:a16="http://schemas.microsoft.com/office/drawing/2014/main" id="{3ED9EBF8-394A-4351-AB6D-1AF851BC352C}"/>
               </a:ext>
             </a:extLst>
           </p:cNvPr>
@@ -5224,7 +5224,7 @@
           <p:cNvPr id="4" name="">
             <a:extLst xmlns:a="http://schemas.openxmlformats.org/drawingml/2006/main">
               <a:ext uri="{FF2B5EF4-FFF2-40B4-BE49-F238E27FC236}">
-                <a16:creationId xmlns:a16="http://schemas.microsoft.com/office/drawing/2014/main" id="{7A65D319-A7ED-44D6-8E77-18EFCED9B854}"/>
+                <a16:creationId xmlns:a16="http://schemas.microsoft.com/office/drawing/2014/main" id="{46E42CCD-9684-43C3-AD70-158BD38B4397}"/>
               </a:ext>
             </a:extLst>
           </p:cNvPr>
@@ -5378,7 +5378,7 @@
     </p:spTree>
     <p:extLst>
       <p:ext uri="{BB962C8B-B14F-4D97-AF65-F5344CB8AC3E}">
-        <p14:creationId xmlns:p14="http://schemas.microsoft.com/office/powerpoint/2010/main" val="243989977"/>
+        <p14:creationId xmlns:p14="http://schemas.microsoft.com/office/powerpoint/2010/main" val="414369282"/>
       </p:ext>
     </p:extLst>
   </p:cSld>
@@ -5409,7 +5409,7 @@
           <p:cNvPr id="5" name="">
             <a:extLst xmlns:a="http://schemas.openxmlformats.org/drawingml/2006/main">
               <a:ext uri="{FF2B5EF4-FFF2-40B4-BE49-F238E27FC236}">
-                <a16:creationId xmlns:a16="http://schemas.microsoft.com/office/drawing/2014/main" id="{F04DB04B-E02F-490C-B1EA-2EC866E66C78}"/>
+                <a16:creationId xmlns:a16="http://schemas.microsoft.com/office/drawing/2014/main" id="{C93670A0-6B30-4329-A967-1EE9E77AF69A}"/>
               </a:ext>
             </a:extLst>
           </p:cNvPr>
@@ -5565,7 +5565,7 @@
           <p:cNvPr id="2" name="">
             <a:extLst xmlns:a="http://schemas.openxmlformats.org/drawingml/2006/main">
               <a:ext uri="{FF2B5EF4-FFF2-40B4-BE49-F238E27FC236}">
-                <a16:creationId xmlns:a16="http://schemas.microsoft.com/office/drawing/2014/main" id="{97747D9D-41BD-4A39-9EA0-24A65B0F7898}"/>
+                <a16:creationId xmlns:a16="http://schemas.microsoft.com/office/drawing/2014/main" id="{8A37E54E-3A2A-4E04-90D8-454C141CF75C}"/>
               </a:ext>
             </a:extLst>
           </p:cNvPr>
@@ -5711,7 +5711,7 @@
                 <a:ea typeface="Arial"/>
                 <a:cs typeface="Arial"/>
               </a:rPr>
-              <a:t>INTERNAL REVIEW  •  Nightshift provider requirement unmet  •  3/6</a:t>
+              <a:t>INTERNAL REVIEW  •  Complete AI investigation remains unmet  •  3/6</a:t>
             </a:r>
           </a:p>
         </p:txBody>
@@ -5721,7 +5721,7 @@
           <p:cNvPr id="3" name="">
             <a:extLst xmlns:a="http://schemas.openxmlformats.org/drawingml/2006/main">
               <a:ext uri="{FF2B5EF4-FFF2-40B4-BE49-F238E27FC236}">
-                <a16:creationId xmlns:a16="http://schemas.microsoft.com/office/drawing/2014/main" id="{4E989A2F-D5BF-42CD-A1FC-1C7306C393BA}"/>
+                <a16:creationId xmlns:a16="http://schemas.microsoft.com/office/drawing/2014/main" id="{FAB80E69-E45C-4A99-A251-C21FEA7AD691}"/>
               </a:ext>
             </a:extLst>
           </p:cNvPr>
@@ -6232,7 +6232,7 @@
           <p:cNvPr id="4" name="">
             <a:extLst xmlns:a="http://schemas.openxmlformats.org/drawingml/2006/main">
               <a:ext uri="{FF2B5EF4-FFF2-40B4-BE49-F238E27FC236}">
-                <a16:creationId xmlns:a16="http://schemas.microsoft.com/office/drawing/2014/main" id="{E78BEC62-1630-440D-9031-F060E5A44028}"/>
+                <a16:creationId xmlns:a16="http://schemas.microsoft.com/office/drawing/2014/main" id="{061B9D7A-9DF7-4332-BA10-95C3A880D940}"/>
               </a:ext>
             </a:extLst>
           </p:cNvPr>
@@ -6386,7 +6386,7 @@
     </p:spTree>
     <p:extLst>
       <p:ext uri="{BB962C8B-B14F-4D97-AF65-F5344CB8AC3E}">
-        <p14:creationId xmlns:p14="http://schemas.microsoft.com/office/powerpoint/2010/main" val="1075415319"/>
+        <p14:creationId xmlns:p14="http://schemas.microsoft.com/office/powerpoint/2010/main" val="1032560349"/>
       </p:ext>
     </p:extLst>
   </p:cSld>
@@ -6417,7 +6417,7 @@
           <p:cNvPr id="9" name="">
             <a:extLst xmlns:a="http://schemas.openxmlformats.org/drawingml/2006/main">
               <a:ext uri="{FF2B5EF4-FFF2-40B4-BE49-F238E27FC236}">
-                <a16:creationId xmlns:a16="http://schemas.microsoft.com/office/drawing/2014/main" id="{FDE0A7A0-11D8-48E2-B32A-E62CB41644F8}"/>
+                <a16:creationId xmlns:a16="http://schemas.microsoft.com/office/drawing/2014/main" id="{2E763A2D-EA88-4F64-AA5A-99CF76D7102C}"/>
               </a:ext>
             </a:extLst>
           </p:cNvPr>
@@ -6573,7 +6573,7 @@
           <p:cNvPr id="2" name="">
             <a:extLst xmlns:a="http://schemas.openxmlformats.org/drawingml/2006/main">
               <a:ext uri="{FF2B5EF4-FFF2-40B4-BE49-F238E27FC236}">
-                <a16:creationId xmlns:a16="http://schemas.microsoft.com/office/drawing/2014/main" id="{4F5BDAE8-540D-4CD1-A9D7-45FBFBEA94B8}"/>
+                <a16:creationId xmlns:a16="http://schemas.microsoft.com/office/drawing/2014/main" id="{9B9A1A6A-CBEF-4BFC-900A-C8E4533327C2}"/>
               </a:ext>
             </a:extLst>
           </p:cNvPr>
@@ -6719,7 +6719,7 @@
                 <a:ea typeface="Arial"/>
                 <a:cs typeface="Arial"/>
               </a:rPr>
-              <a:t>INTERNAL REVIEW  •  Nightshift provider requirement unmet  •  4/6</a:t>
+              <a:t>INTERNAL REVIEW  •  Complete AI investigation remains unmet  •  4/6</a:t>
             </a:r>
           </a:p>
         </p:txBody>
@@ -6729,7 +6729,7 @@
           <p:cNvPr id="3" name="">
             <a:extLst xmlns:a="http://schemas.openxmlformats.org/drawingml/2006/main">
               <a:ext uri="{FF2B5EF4-FFF2-40B4-BE49-F238E27FC236}">
-                <a16:creationId xmlns:a16="http://schemas.microsoft.com/office/drawing/2014/main" id="{706A09C7-0CBD-4F9D-86F1-C5CF445EFDA7}"/>
+                <a16:creationId xmlns:a16="http://schemas.microsoft.com/office/drawing/2014/main" id="{23FD97A9-38E0-4749-A431-4FEFF484CFEC}"/>
               </a:ext>
             </a:extLst>
           </p:cNvPr>
@@ -6885,7 +6885,7 @@
           <p:cNvPr id="4" name="">
             <a:extLst xmlns:a="http://schemas.openxmlformats.org/drawingml/2006/main">
               <a:ext uri="{FF2B5EF4-FFF2-40B4-BE49-F238E27FC236}">
-                <a16:creationId xmlns:a16="http://schemas.microsoft.com/office/drawing/2014/main" id="{F9DBB0FE-EE2C-4012-B6B4-5DA151A9140A}"/>
+                <a16:creationId xmlns:a16="http://schemas.microsoft.com/office/drawing/2014/main" id="{DF298488-0439-47AB-BF44-22C90FDE8B57}"/>
               </a:ext>
             </a:extLst>
           </p:cNvPr>
@@ -7041,7 +7041,7 @@
           <p:cNvPr id="5" name="">
             <a:extLst xmlns:a="http://schemas.openxmlformats.org/drawingml/2006/main">
               <a:ext uri="{FF2B5EF4-FFF2-40B4-BE49-F238E27FC236}">
-                <a16:creationId xmlns:a16="http://schemas.microsoft.com/office/drawing/2014/main" id="{5F6971AB-3066-4F38-AB03-B2650F81CEFF}"/>
+                <a16:creationId xmlns:a16="http://schemas.microsoft.com/office/drawing/2014/main" id="{4D4F3E04-EB2C-4308-ACD7-23331FBC01E2}"/>
               </a:ext>
             </a:extLst>
           </p:cNvPr>
@@ -7197,7 +7197,7 @@
           <p:cNvPr id="6" name="">
             <a:extLst xmlns:a="http://schemas.openxmlformats.org/drawingml/2006/main">
               <a:ext uri="{FF2B5EF4-FFF2-40B4-BE49-F238E27FC236}">
-                <a16:creationId xmlns:a16="http://schemas.microsoft.com/office/drawing/2014/main" id="{71AD84E5-29B6-451E-BA3A-9AAF4C0690F7}"/>
+                <a16:creationId xmlns:a16="http://schemas.microsoft.com/office/drawing/2014/main" id="{33783F7B-AD45-488C-9C33-86F76B4BE97A}"/>
               </a:ext>
             </a:extLst>
           </p:cNvPr>
@@ -7353,7 +7353,7 @@
           <p:cNvPr id="7" name="">
             <a:extLst xmlns:a="http://schemas.openxmlformats.org/drawingml/2006/main">
               <a:ext uri="{FF2B5EF4-FFF2-40B4-BE49-F238E27FC236}">
-                <a16:creationId xmlns:a16="http://schemas.microsoft.com/office/drawing/2014/main" id="{DA61C3A8-A43E-4E24-B734-D5068303E9EA}"/>
+                <a16:creationId xmlns:a16="http://schemas.microsoft.com/office/drawing/2014/main" id="{FDD70887-CE96-4221-891F-D7E2C4D47701}"/>
               </a:ext>
             </a:extLst>
           </p:cNvPr>
@@ -7509,7 +7509,7 @@
           <p:cNvPr id="8" name="">
             <a:extLst xmlns:a="http://schemas.openxmlformats.org/drawingml/2006/main">
               <a:ext uri="{FF2B5EF4-FFF2-40B4-BE49-F238E27FC236}">
-                <a16:creationId xmlns:a16="http://schemas.microsoft.com/office/drawing/2014/main" id="{FCD77B42-7939-4B82-92E3-E872F7805C4E}"/>
+                <a16:creationId xmlns:a16="http://schemas.microsoft.com/office/drawing/2014/main" id="{FEF17719-94FB-420B-9B27-B99340A05313}"/>
               </a:ext>
             </a:extLst>
           </p:cNvPr>
@@ -7663,7 +7663,7 @@
     </p:spTree>
     <p:extLst>
       <p:ext uri="{BB962C8B-B14F-4D97-AF65-F5344CB8AC3E}">
-        <p14:creationId xmlns:p14="http://schemas.microsoft.com/office/powerpoint/2010/main" val="1267677705"/>
+        <p14:creationId xmlns:p14="http://schemas.microsoft.com/office/powerpoint/2010/main" val="1679679361"/>
       </p:ext>
     </p:extLst>
   </p:cSld>
@@ -7694,7 +7694,7 @@
           <p:cNvPr id="4" name="">
             <a:extLst xmlns:a="http://schemas.openxmlformats.org/drawingml/2006/main">
               <a:ext uri="{FF2B5EF4-FFF2-40B4-BE49-F238E27FC236}">
-                <a16:creationId xmlns:a16="http://schemas.microsoft.com/office/drawing/2014/main" id="{A43789EA-4A6E-4FE9-A0F9-B0298B1CB7E3}"/>
+                <a16:creationId xmlns:a16="http://schemas.microsoft.com/office/drawing/2014/main" id="{269CA956-20C7-4033-A535-C3E654919EAC}"/>
               </a:ext>
             </a:extLst>
           </p:cNvPr>
@@ -7850,7 +7850,7 @@
           <p:cNvPr id="2" name="">
             <a:extLst xmlns:a="http://schemas.openxmlformats.org/drawingml/2006/main">
               <a:ext uri="{FF2B5EF4-FFF2-40B4-BE49-F238E27FC236}">
-                <a16:creationId xmlns:a16="http://schemas.microsoft.com/office/drawing/2014/main" id="{BEFCC841-E125-4CF8-9C2D-A652A88D81D7}"/>
+                <a16:creationId xmlns:a16="http://schemas.microsoft.com/office/drawing/2014/main" id="{7E74691A-8B1B-4D1D-BFB0-C490D4B3D626}"/>
               </a:ext>
             </a:extLst>
           </p:cNvPr>
@@ -7996,7 +7996,7 @@
                 <a:ea typeface="Arial"/>
                 <a:cs typeface="Arial"/>
               </a:rPr>
-              <a:t>INTERNAL REVIEW  •  Nightshift provider requirement unmet  •  5/6</a:t>
+              <a:t>INTERNAL REVIEW  •  Complete AI investigation remains unmet  •  5/6</a:t>
             </a:r>
           </a:p>
         </p:txBody>
@@ -8006,7 +8006,7 @@
           <p:cNvPr id="3" name="">
             <a:extLst xmlns:a="http://schemas.openxmlformats.org/drawingml/2006/main">
               <a:ext uri="{FF2B5EF4-FFF2-40B4-BE49-F238E27FC236}">
-                <a16:creationId xmlns:a16="http://schemas.microsoft.com/office/drawing/2014/main" id="{98FDFC11-8749-4038-8992-7BDBD108EE28}"/>
+                <a16:creationId xmlns:a16="http://schemas.microsoft.com/office/drawing/2014/main" id="{10229904-25F0-42AE-BB2E-266857F37733}"/>
               </a:ext>
             </a:extLst>
           </p:cNvPr>
@@ -8565,7 +8565,7 @@
                           <a:ea typeface="Arial"/>
                           <a:cs typeface="Arial"/>
                         </a:rPr>
-                        <a:t>Official installation and CLI checked</a:t>
+                        <a:t>Authenticated NVIDIA inference and native proposal verified</a:t>
                       </a:r>
                     </a:p>
                   </a:txBody>
@@ -8601,7 +8601,7 @@
                           <a:ea typeface="Arial"/>
                           <a:cs typeface="Arial"/>
                         </a:rPr>
-                        <a:t>MANDATORY GAP: Runtime unreachable; cloud-only startup unverified</a:t>
+                        <a:t>Financial proposal rejected; no completed AI briefing</a:t>
                       </a:r>
                     </a:p>
                   </a:txBody>
@@ -8747,7 +8747,7 @@
     </p:spTree>
     <p:extLst>
       <p:ext uri="{BB962C8B-B14F-4D97-AF65-F5344CB8AC3E}">
-        <p14:creationId xmlns:p14="http://schemas.microsoft.com/office/powerpoint/2010/main" val="1527798176"/>
+        <p14:creationId xmlns:p14="http://schemas.microsoft.com/office/powerpoint/2010/main" val="180884134"/>
       </p:ext>
     </p:extLst>
   </p:cSld>
@@ -8778,7 +8778,7 @@
           <p:cNvPr id="15" name="">
             <a:extLst xmlns:a="http://schemas.openxmlformats.org/drawingml/2006/main">
               <a:ext uri="{FF2B5EF4-FFF2-40B4-BE49-F238E27FC236}">
-                <a16:creationId xmlns:a16="http://schemas.microsoft.com/office/drawing/2014/main" id="{8AF16A5E-7F7D-4324-B63B-CFFC69CECE49}"/>
+                <a16:creationId xmlns:a16="http://schemas.microsoft.com/office/drawing/2014/main" id="{618973DC-C84E-4CDC-A272-26F5E3821300}"/>
               </a:ext>
             </a:extLst>
           </p:cNvPr>
@@ -8934,7 +8934,7 @@
           <p:cNvPr id="2" name="">
             <a:extLst xmlns:a="http://schemas.openxmlformats.org/drawingml/2006/main">
               <a:ext uri="{FF2B5EF4-FFF2-40B4-BE49-F238E27FC236}">
-                <a16:creationId xmlns:a16="http://schemas.microsoft.com/office/drawing/2014/main" id="{C802EB41-B0A4-453E-B235-6EB7DB1E7BCC}"/>
+                <a16:creationId xmlns:a16="http://schemas.microsoft.com/office/drawing/2014/main" id="{E8B1D71D-7BCA-4F3B-ADE1-B341C9B53821}"/>
               </a:ext>
             </a:extLst>
           </p:cNvPr>
@@ -9080,7 +9080,7 @@
                 <a:ea typeface="Arial"/>
                 <a:cs typeface="Arial"/>
               </a:rPr>
-              <a:t>INTERNAL REVIEW  •  Nightshift provider requirement unmet  •  6/6</a:t>
+              <a:t>INTERNAL REVIEW  •  Complete AI investigation remains unmet  •  6/6</a:t>
             </a:r>
           </a:p>
         </p:txBody>
@@ -9090,7 +9090,7 @@
           <p:cNvPr id="3" name="">
             <a:extLst xmlns:a="http://schemas.openxmlformats.org/drawingml/2006/main">
               <a:ext uri="{FF2B5EF4-FFF2-40B4-BE49-F238E27FC236}">
-                <a16:creationId xmlns:a16="http://schemas.microsoft.com/office/drawing/2014/main" id="{F61AE088-E223-4592-8D8B-CF3AF0DE8556}"/>
+                <a16:creationId xmlns:a16="http://schemas.microsoft.com/office/drawing/2014/main" id="{793FADBC-AEF9-4F7F-8C8F-B2157B01A6AA}"/>
               </a:ext>
             </a:extLst>
           </p:cNvPr>
@@ -9246,7 +9246,7 @@
           <p:cNvPr id="4" name="">
             <a:extLst xmlns:a="http://schemas.openxmlformats.org/drawingml/2006/main">
               <a:ext uri="{FF2B5EF4-FFF2-40B4-BE49-F238E27FC236}">
-                <a16:creationId xmlns:a16="http://schemas.microsoft.com/office/drawing/2014/main" id="{AF82150E-724E-47CB-9A14-95A6B46B8C00}"/>
+                <a16:creationId xmlns:a16="http://schemas.microsoft.com/office/drawing/2014/main" id="{E9C311BB-6AE9-481D-9A87-93A8C8E38D69}"/>
               </a:ext>
             </a:extLst>
           </p:cNvPr>
@@ -9392,7 +9392,7 @@
                 <a:ea typeface="Arial"/>
                 <a:cs typeface="Arial"/>
               </a:rPr>
-              <a:t>Resolve the mandatory Nightshift provider gap</a:t>
+              <a:t>Complete a valid model financial investigation</a:t>
             </a:r>
           </a:p>
         </p:txBody>
@@ -9402,7 +9402,7 @@
           <p:cNvPr id="5" name="">
             <a:extLst xmlns:a="http://schemas.openxmlformats.org/drawingml/2006/main">
               <a:ext uri="{FF2B5EF4-FFF2-40B4-BE49-F238E27FC236}">
-                <a16:creationId xmlns:a16="http://schemas.microsoft.com/office/drawing/2014/main" id="{9F4B4637-1800-4009-833F-CB7DA8BAC6FA}"/>
+                <a16:creationId xmlns:a16="http://schemas.microsoft.com/office/drawing/2014/main" id="{293BEDCD-C507-40CA-99CF-897FF9F1A2B0}"/>
               </a:ext>
             </a:extLst>
           </p:cNvPr>
@@ -9548,7 +9548,7 @@
                 <a:ea typeface="Arial"/>
                 <a:cs typeface="Arial"/>
               </a:rPr>
-              <a:t>Confirm supported cloud-only startup or obtain an authorized compatible host.</a:t>
+              <a:t>A valid proposal and full investigation remain future work. No further model retries now.</a:t>
             </a:r>
           </a:p>
         </p:txBody>
@@ -9558,7 +9558,7 @@
           <p:cNvPr id="6" name="">
             <a:extLst xmlns:a="http://schemas.openxmlformats.org/drawingml/2006/main">
               <a:ext uri="{FF2B5EF4-FFF2-40B4-BE49-F238E27FC236}">
-                <a16:creationId xmlns:a16="http://schemas.microsoft.com/office/drawing/2014/main" id="{1ED73154-989A-404E-A632-440E7D0A238D}"/>
+                <a16:creationId xmlns:a16="http://schemas.microsoft.com/office/drawing/2014/main" id="{9A244880-5996-4AD3-8584-6001E2C59E04}"/>
               </a:ext>
             </a:extLst>
           </p:cNvPr>
@@ -9714,7 +9714,7 @@
           <p:cNvPr id="7" name="">
             <a:extLst xmlns:a="http://schemas.openxmlformats.org/drawingml/2006/main">
               <a:ext uri="{FF2B5EF4-FFF2-40B4-BE49-F238E27FC236}">
-                <a16:creationId xmlns:a16="http://schemas.microsoft.com/office/drawing/2014/main" id="{4514BC0A-6642-4729-A89E-93B3C37E80E7}"/>
+                <a16:creationId xmlns:a16="http://schemas.microsoft.com/office/drawing/2014/main" id="{2E358051-A5D3-4A86-81D0-FD99C39AFFC1}"/>
               </a:ext>
             </a:extLst>
           </p:cNvPr>
@@ -9860,7 +9860,7 @@
                 <a:ea typeface="Arial"/>
                 <a:cs typeface="Arial"/>
               </a:rPr>
-              <a:t>Approve reviewed changes and judge access</a:t>
+              <a:t>Confirm judge access to the merged application</a:t>
             </a:r>
           </a:p>
         </p:txBody>
@@ -9870,7 +9870,7 @@
           <p:cNvPr id="8" name="">
             <a:extLst xmlns:a="http://schemas.openxmlformats.org/drawingml/2006/main">
               <a:ext uri="{FF2B5EF4-FFF2-40B4-BE49-F238E27FC236}">
-                <a16:creationId xmlns:a16="http://schemas.microsoft.com/office/drawing/2014/main" id="{C3BA373F-CB2B-45E1-A2CE-001D015E73B5}"/>
+                <a16:creationId xmlns:a16="http://schemas.microsoft.com/office/drawing/2014/main" id="{E520CEEF-FE3C-427E-8592-07DCAAE8CEB1}"/>
               </a:ext>
             </a:extLst>
           </p:cNvPr>
@@ -10016,7 +10016,7 @@
                 <a:ea typeface="Arial"/>
                 <a:cs typeface="Arial"/>
               </a:rPr>
-              <a:t>PRs remain unmerged; the repository is private until the lead approves access.</a:t>
+              <a:t>PRs 7–13 are merged. Public main is 0a6f6fb. Verify judge access and links.</a:t>
             </a:r>
           </a:p>
         </p:txBody>
@@ -10026,7 +10026,7 @@
           <p:cNvPr id="9" name="">
             <a:extLst xmlns:a="http://schemas.openxmlformats.org/drawingml/2006/main">
               <a:ext uri="{FF2B5EF4-FFF2-40B4-BE49-F238E27FC236}">
-                <a16:creationId xmlns:a16="http://schemas.microsoft.com/office/drawing/2014/main" id="{8D560A4C-6E20-46C9-AE08-779370C84E59}"/>
+                <a16:creationId xmlns:a16="http://schemas.microsoft.com/office/drawing/2014/main" id="{E54E1DA3-61EE-4098-973F-83B0AF903671}"/>
               </a:ext>
             </a:extLst>
           </p:cNvPr>
@@ -10182,7 +10182,7 @@
           <p:cNvPr id="10" name="">
             <a:extLst xmlns:a="http://schemas.openxmlformats.org/drawingml/2006/main">
               <a:ext uri="{FF2B5EF4-FFF2-40B4-BE49-F238E27FC236}">
-                <a16:creationId xmlns:a16="http://schemas.microsoft.com/office/drawing/2014/main" id="{E9A97430-F53D-4FC0-9D63-2591A787429F}"/>
+                <a16:creationId xmlns:a16="http://schemas.microsoft.com/office/drawing/2014/main" id="{9D3C19AA-0743-4A87-ABDE-CE48B52966EE}"/>
               </a:ext>
             </a:extLst>
           </p:cNvPr>
@@ -10338,7 +10338,7 @@
           <p:cNvPr id="11" name="">
             <a:extLst xmlns:a="http://schemas.openxmlformats.org/drawingml/2006/main">
               <a:ext uri="{FF2B5EF4-FFF2-40B4-BE49-F238E27FC236}">
-                <a16:creationId xmlns:a16="http://schemas.microsoft.com/office/drawing/2014/main" id="{5A632D34-9A2B-42FA-856C-23FBB3860B57}"/>
+                <a16:creationId xmlns:a16="http://schemas.microsoft.com/office/drawing/2014/main" id="{F4BF83F9-9062-41A8-8415-2E7896D65066}"/>
               </a:ext>
             </a:extLst>
           </p:cNvPr>
@@ -10484,7 +10484,7 @@
                 <a:ea typeface="Arial"/>
                 <a:cs typeface="Arial"/>
               </a:rPr>
-              <a:t>Confirm a 1–4-minute video, readable traces and these accurate sponsor disclosures.</a:t>
+              <a:t>Review the updated video and deck. Prepared HackOS draft includes uploaded media.</a:t>
             </a:r>
           </a:p>
         </p:txBody>
@@ -10494,7 +10494,7 @@
           <p:cNvPr id="12" name="">
             <a:extLst xmlns:a="http://schemas.openxmlformats.org/drawingml/2006/main">
               <a:ext uri="{FF2B5EF4-FFF2-40B4-BE49-F238E27FC236}">
-                <a16:creationId xmlns:a16="http://schemas.microsoft.com/office/drawing/2014/main" id="{C96DFBB6-8B6C-452E-B6D6-5C26CDA5FDBD}"/>
+                <a16:creationId xmlns:a16="http://schemas.microsoft.com/office/drawing/2014/main" id="{4999E053-1A2F-46EC-B929-C8BE7F09B21A}"/>
               </a:ext>
             </a:extLst>
           </p:cNvPr>
@@ -10650,7 +10650,7 @@
           <p:cNvPr id="13" name="">
             <a:extLst xmlns:a="http://schemas.openxmlformats.org/drawingml/2006/main">
               <a:ext uri="{FF2B5EF4-FFF2-40B4-BE49-F238E27FC236}">
-                <a16:creationId xmlns:a16="http://schemas.microsoft.com/office/drawing/2014/main" id="{02461B21-A272-4245-A562-61283487D27E}"/>
+                <a16:creationId xmlns:a16="http://schemas.microsoft.com/office/drawing/2014/main" id="{43C41939-04BD-4A21-9A8D-7C643CE228B4}"/>
               </a:ext>
             </a:extLst>
           </p:cNvPr>
@@ -10806,7 +10806,7 @@
           <p:cNvPr id="14" name="">
             <a:extLst xmlns:a="http://schemas.openxmlformats.org/drawingml/2006/main">
               <a:ext uri="{FF2B5EF4-FFF2-40B4-BE49-F238E27FC236}">
-                <a16:creationId xmlns:a16="http://schemas.microsoft.com/office/drawing/2014/main" id="{08545D72-A9DA-42A9-B6B3-B02256B8BCE6}"/>
+                <a16:creationId xmlns:a16="http://schemas.microsoft.com/office/drawing/2014/main" id="{E5BBD462-582D-40F5-8F04-5E264D19C5D5}"/>
               </a:ext>
             </a:extLst>
           </p:cNvPr>
@@ -10952,7 +10952,7 @@
                 <a:ea typeface="Arial"/>
                 <a:cs typeface="Arial"/>
               </a:rPr>
-              <a:t>Check the registered roster, pre-existing components, artifact links and final organizer form.</a:t>
+              <a:t>Solo roster: Amari. Check disclosures and links. Final submission still requires lead approval.</a:t>
             </a:r>
           </a:p>
         </p:txBody>
@@ -10960,7 +10960,7 @@
     </p:spTree>
     <p:extLst>
       <p:ext uri="{BB962C8B-B14F-4D97-AF65-F5344CB8AC3E}">
-        <p14:creationId xmlns:p14="http://schemas.microsoft.com/office/powerpoint/2010/main" val="1186904747"/>
+        <p14:creationId xmlns:p14="http://schemas.microsoft.com/office/powerpoint/2010/main" val="125477331"/>
       </p:ext>
     </p:extLst>
   </p:cSld>

</xml_diff>